<commit_message>
Se corrige el alcance de la navegacion temporal y se retiran las notas del PPT
El informe y la presentacion describian un drill-down por jerarquia de tiempo
que el dashboard no implementa: los visuales de serie temporal se excluyeron
por el problema de cobertura documentado en la seccion 6.6. Se sustituye por
la navegacion que si existe, mediante el segmentador de periodo.
</commit_message>
<xml_diff>
--- a/ppt/Exposicion_Proyecto_Final.pptx
+++ b/ppt/Exposicion_Proyecto_Final.pptx
@@ -509,11 +509,7 @@
         <p:txBody>
           <a:bodyPr/>
           <a:lstStyle/>
-          <a:p>
-            <a:r>
-              <a:t>Presentarme y decir el titulo. Aclarar de entrada que es un proyecto individual y que por eso asumo todos los roles. No leer la lamina: solo decir que se trata de una solucion BI completa sobre datos reales de validaciones de transporte urbano peruano. 30 segundos.</a:t>
-            </a:r>
-          </a:p>
+          <a:p/>
         </p:txBody>
       </p:sp>
       <p:sp>
@@ -579,11 +575,7 @@
         <p:txBody>
           <a:bodyPr/>
           <a:lstStyle/>
-          <a:p>
-            <a:r>
-              <a:t>No leer las conclusiones una por una: elegir dos y desarrollarlas. La quinta, la de etica, es la que menos gente trabaja y la que la rubrica pide expresamente. Dejar tiempo para preguntas y responder con calma. Si no se sabe algo, decirlo y explicar como se averiguaria. 45 segundos.</a:t>
-            </a:r>
-          </a:p>
+          <a:p/>
         </p:txBody>
       </p:sp>
       <p:sp>
@@ -649,11 +641,7 @@
         <p:txBody>
           <a:bodyPr/>
           <a:lstStyle/>
-          <a:p>
-            <a:r>
-              <a:t>El mensaje central: no es un problema de falta de datos, es de falta de estructura. Tienen millones de registros y no pueden responder preguntas basicas de planificacion. Esa es la brecha que cierra el proyecto. Si preguntan por el sector: corredor complementario, transporte urbano peruano. 60 segundos.</a:t>
-            </a:r>
-          </a:p>
+          <a:p/>
         </p:txBody>
       </p:sp>
       <p:sp>
@@ -719,11 +707,7 @@
         <p:txBody>
           <a:bodyPr/>
           <a:lstStyle/>
-          <a:p>
-            <a:r>
-              <a:t>Recorrer el flujo de izquierda a derecha en una frase por capa. Lo importante son las tres razones de abajo: si el docente pregunta 'por que no consultas directo la base operativa', esa es la respuesta. Mencionar que todo el stack es gratuito. 90 segundos.</a:t>
-            </a:r>
-          </a:p>
+          <a:p/>
         </p:txBody>
       </p:sp>
       <p:sp>
@@ -789,11 +773,7 @@
         <p:txBody>
           <a:bodyPr/>
           <a:lstStyle/>
-          <a:p>
-            <a:r>
-              <a:t>Esta es la lamina donde se demuestra dominio del modelado. El argumento de las dos tablas de hechos es lo mas defendible del diseno: explica que el grano determina que puedes medir. Si preguntan que es una constelacion: varios hechos compartiendo las mismas dimensiones. 90 segundos.</a:t>
-            </a:r>
-          </a:p>
+          <a:p/>
         </p:txBody>
       </p:sp>
       <p:sp>
@@ -859,11 +839,7 @@
         <p:txBody>
           <a:bodyPr/>
           <a:lstStyle/>
-          <a:p>
-            <a:r>
-              <a:t>La derivacion del tipo de pasaje es el punto fuerte: mostrar que hubo que inferir una dimension que no existia, y que se hizo por ruta y por mes porque la tarifa cambia. Si preguntan por que no se separa escolar de universitario: pagan la misma tarifa, es indistinguible desde el monto. Cerrar con la conciliacion. 2 minutos.</a:t>
-            </a:r>
-          </a:p>
+          <a:p/>
         </p:txBody>
       </p:sp>
       <p:sp>
@@ -929,11 +905,7 @@
         <p:txBody>
           <a:bodyPr/>
           <a:lstStyle/>
-          <a:p>
-            <a:r>
-              <a:t>IMPORTANTE. Esta lamina anticipa la pregunta dificil. Si el docente ve un grafico mensual con caidas y pregunta que paso en marzo, la respuesta es cobertura, no demanda. Presentarlo como hallazgo del perfilado, con seguridad: detectarlo y declararlo es rigor metodologico. No pedir disculpas por el dato. 90 segundos.</a:t>
-            </a:r>
-          </a:p>
+          <a:p/>
         </p:txBody>
       </p:sp>
       <p:sp>
@@ -999,11 +971,7 @@
         <p:txBody>
           <a:bodyPr/>
           <a:lstStyle/>
-          <a:p>
-            <a:r>
-              <a:t>AQUI SE CAMBIA A POWER BI. No leer los numeros de la lamina, mostrarlos funcionando. Filtrar una ruta, hacer drill-down, y detenerse en el grafico de horas punta para conectar con la recomendacion de frecuencias. Tener la pestana ya abierta y con sesion iniciada ANTES de empezar. 2 minutos de demo.</a:t>
-            </a:r>
-          </a:p>
+          <a:p/>
         </p:txBody>
       </p:sp>
       <p:sp>
@@ -1069,11 +1037,7 @@
         <p:txBody>
           <a:bodyPr/>
           <a:lstStyle/>
-          <a:p>
-            <a:r>
-              <a:t>AQUI SE CAMBIA AL MODULO DE IA. Elegir una ruta, generar el analisis en vivo y leer un hallazgo de los que devuelva. Recalcar lo de la clave: es el punto de seguridad que diferencia una integracion seria de una hecha a la ligera. Mencionar que el repositorio esta publicado y que funciona colocando la propia API Key. 2 minutos de demo.</a:t>
-            </a:r>
-          </a:p>
+          <a:p/>
         </p:txBody>
       </p:sp>
       <p:sp>
@@ -1139,11 +1103,7 @@
         <p:txBody>
           <a:bodyPr/>
           <a:lstStyle/>
-          <a:p>
-            <a:r>
-              <a:t>Cerrar con el mensaje del recuadro azul: el hallazgo mas importante solo aparece cuando consolidas el historico. Eso justifica todo el proyecto. Si preguntan por R-12: es una ruta alimentadora con tarifa menor, no necesariamente un fraude, pero merece revision. 90 segundos.</a:t>
-            </a:r>
-          </a:p>
+          <a:p/>
         </p:txBody>
       </p:sp>
       <p:sp>
@@ -10632,7 +10592,7 @@
                 </a:solidFill>
                 <a:latin typeface="Segoe UI"/>
               </a:rPr>
-              <a:t>2.  Drill-down en la jerarquia de tiempo: ano, trimestre, mes.</a:t>
+              <a:t>2.  Filtrar por un mes y comprobar que todos los visuales reaccionan.</a:t>
             </a:r>
           </a:p>
           <a:p>
@@ -10648,7 +10608,7 @@
                 </a:solidFill>
                 <a:latin typeface="Segoe UI"/>
               </a:rPr>
-              <a:t>3.  Grafico de demanda por hora: las dos horas punta se ven a simple vista.</a:t>
+              <a:t>3.  Cambiar a la pagina 2: las dos horas punta se ven a simple vista.</a:t>
             </a:r>
           </a:p>
         </p:txBody>

</xml_diff>